<commit_message>
Remove guide name; add step-by-step run guide, .env guidance and AI key setup
Co-Authored-By: Claude Sonnet 5.5 <noreply@anthropic.com>
</commit_message>
<xml_diff>
--- a/docs/exports/08_Presentation.pptx
+++ b/docs/exports/08_Presentation.pptx
@@ -4717,7 +4717,7 @@
                 </a:solidFill>
                 <a:latin typeface="Calibri"/>
               </a:rPr>
-              <a:t>Guide: Dr. Asesh Kumar Tripathy | KL University | AY 2026-27</a:t>
+              <a:t>KL University | AY 2026-27</a:t>
             </a:r>
           </a:p>
           <a:p>
@@ -6356,22 +6356,6 @@
                 <a:latin typeface="Calibri"/>
               </a:rPr>
               <a:t>•  Devi Priya, Priyanka, Akshay and Bhaskar</a:t>
-            </a:r>
-          </a:p>
-          <a:p>
-            <a:pPr>
-              <a:spcAft>
-                <a:spcPts val="1000"/>
-              </a:spcAft>
-            </a:pPr>
-            <a:r>
-              <a:rPr sz="1900">
-                <a:solidFill>
-                  <a:srgbClr val="111111"/>
-                </a:solidFill>
-                <a:latin typeface="Calibri"/>
-              </a:rPr>
-              <a:t>•  Guide: Dr. Asesh Kumar Tripathy</a:t>
             </a:r>
           </a:p>
           <a:p>

</xml_diff>